<commit_message>
Recolor slide deck to match reference chart palette
Sampled the user-supplied reference deck's chart images (Office 2021+
default chart colors, #156082 blue / #E97132 orange) and swapped the
deck's blue/orange constants to match, keeping the same native-chart
structure, layout, and dashed-gridline styling.
</commit_message>
<xml_diff>
--- a/lecanemab-slides/lecanemab_analysis_slides.pptx
+++ b/lecanemab-slides/lecanemab_analysis_slides.pptx
@@ -139,7 +139,7 @@
           </c:tx>
           <c:spPr>
             <a:solidFill>
-              <a:srgbClr val="1F6FB2"/>
+              <a:srgbClr val="156082"/>
             </a:solidFill>
             <a:effectLst/>
           </c:spPr>
@@ -308,7 +308,7 @@
           </c:tx>
           <c:spPr>
             <a:solidFill>
-              <a:srgbClr val="ED7D31"/>
+              <a:srgbClr val="E97132"/>
             </a:solidFill>
             <a:effectLst/>
           </c:spPr>
@@ -657,7 +657,7 @@
           </c:tx>
           <c:spPr>
             <a:solidFill>
-              <a:srgbClr val="1F6FB2"/>
+              <a:srgbClr val="156082"/>
             </a:solidFill>
             <a:effectLst/>
           </c:spPr>
@@ -1142,7 +1142,7 @@
           </c:tx>
           <c:spPr>
             <a:solidFill>
-              <a:srgbClr val="1F6FB2"/>
+              <a:srgbClr val="156082"/>
             </a:solidFill>
             <a:effectLst/>
           </c:spPr>
@@ -1315,7 +1315,7 @@
             <c:bubble3D val="0"/>
             <c:spPr>
               <a:solidFill>
-                <a:srgbClr val="1F6FB2"/>
+                <a:srgbClr val="156082"/>
               </a:solidFill>
               <a:effectLst/>
             </c:spPr>
@@ -1326,7 +1326,7 @@
             <c:bubble3D val="0"/>
             <c:spPr>
               <a:solidFill>
-                <a:srgbClr val="1F6FB2"/>
+                <a:srgbClr val="156082"/>
               </a:solidFill>
               <a:effectLst/>
             </c:spPr>
@@ -1337,7 +1337,7 @@
             <c:bubble3D val="0"/>
             <c:spPr>
               <a:solidFill>
-                <a:srgbClr val="ED7D31"/>
+                <a:srgbClr val="E97132"/>
               </a:solidFill>
               <a:effectLst/>
             </c:spPr>
@@ -1559,7 +1559,7 @@
           </c:tx>
           <c:spPr>
             <a:solidFill>
-              <a:srgbClr val="1F6FB2"/>
+              <a:srgbClr val="156082"/>
             </a:solidFill>
             <a:effectLst/>
           </c:spPr>
@@ -1686,7 +1686,7 @@
             <c:bubble3D val="0"/>
             <c:spPr>
               <a:solidFill>
-                <a:srgbClr val="1F6FB2"/>
+                <a:srgbClr val="156082"/>
               </a:solidFill>
               <a:effectLst/>
             </c:spPr>
@@ -1697,7 +1697,7 @@
             <c:bubble3D val="0"/>
             <c:spPr>
               <a:solidFill>
-                <a:srgbClr val="ED7D31"/>
+                <a:srgbClr val="E97132"/>
               </a:solidFill>
               <a:effectLst/>
             </c:spPr>
@@ -1910,7 +1910,7 @@
           </c:tx>
           <c:spPr>
             <a:solidFill>
-              <a:srgbClr val="1F6FB2"/>
+              <a:srgbClr val="156082"/>
             </a:solidFill>
             <a:effectLst/>
           </c:spPr>
@@ -1945,7 +1945,7 @@
             <c:bubble3D val="0"/>
             <c:spPr>
               <a:solidFill>
-                <a:srgbClr val="1F6FB2"/>
+                <a:srgbClr val="156082"/>
               </a:solidFill>
               <a:effectLst/>
             </c:spPr>
@@ -1956,7 +1956,7 @@
             <c:bubble3D val="0"/>
             <c:spPr>
               <a:solidFill>
-                <a:srgbClr val="ED7D31"/>
+                <a:srgbClr val="E97132"/>
               </a:solidFill>
               <a:effectLst/>
             </c:spPr>
@@ -2169,11 +2169,11 @@
           </c:tx>
           <c:spPr>
             <a:solidFill>
-              <a:srgbClr val="1F6FB2"/>
+              <a:srgbClr val="156082"/>
             </a:solidFill>
             <a:ln w="28575" cap="flat">
               <a:solidFill>
-                <a:srgbClr val="1F6FB2"/>
+                <a:srgbClr val="156082"/>
               </a:solidFill>
               <a:prstDash val="solid"/>
               <a:round/>
@@ -2395,11 +2395,11 @@
             <c:size val="6"/>
             <c:spPr>
               <a:solidFill>
-                <a:srgbClr val="1F6FB2"/>
+                <a:srgbClr val="156082"/>
               </a:solidFill>
               <a:ln w="9525" cap="flat">
                 <a:solidFill>
-                  <a:srgbClr val="1F6FB2"/>
+                  <a:srgbClr val="156082"/>
                 </a:solidFill>
                 <a:prstDash val="solid"/>
                 <a:round/>
@@ -2468,11 +2468,11 @@
           </c:tx>
           <c:spPr>
             <a:solidFill>
-              <a:srgbClr val="ED7D31"/>
+              <a:srgbClr val="E97132"/>
             </a:solidFill>
             <a:ln w="28575" cap="flat">
               <a:solidFill>
-                <a:srgbClr val="ED7D31"/>
+                <a:srgbClr val="E97132"/>
               </a:solidFill>
               <a:prstDash val="solid"/>
               <a:round/>
@@ -2694,11 +2694,11 @@
             <c:size val="6"/>
             <c:spPr>
               <a:solidFill>
-                <a:srgbClr val="ED7D31"/>
+                <a:srgbClr val="E97132"/>
               </a:solidFill>
               <a:ln w="9525" cap="flat">
                 <a:solidFill>
-                  <a:srgbClr val="ED7D31"/>
+                  <a:srgbClr val="E97132"/>
                 </a:solidFill>
                 <a:prstDash val="solid"/>
                 <a:round/>
@@ -4138,7 +4138,7 @@
           </a:solidFill>
           <a:ln w="15875">
             <a:solidFill>
-              <a:srgbClr val="1F6FB2"/>
+              <a:srgbClr val="156082"/>
             </a:solidFill>
             <a:prstDash val="solid"/>
           </a:ln>
@@ -6120,7 +6120,7 @@
           </a:solidFill>
           <a:ln w="15875">
             <a:solidFill>
-              <a:srgbClr val="1F6FB2"/>
+              <a:srgbClr val="156082"/>
             </a:solidFill>
             <a:prstDash val="solid"/>
           </a:ln>

</xml_diff>

<commit_message>
Restyle deck toward the supervising physician's own slide conventions
Reverse-engineered the reference deck (his actual conference slides) at
the XML level: mixed Arial(Latin)/MS Pゴシック(Japanese) typeface per
run, a thin accent-blue rule spanning the full content width directly
under every title block, and red-bold emphasis on the single headline
number per slide/chart (matching how his own tables reserve red for the
one number he wants the audience to remember, not for p-values). Kept
the Baseline table's English/serif styling and the established chart
layout, colors, and native-chart structure unchanged.
</commit_message>
<xml_diff>
--- a/lecanemab-slides/lecanemab_analysis_slides.pptx
+++ b/lecanemab-slides/lecanemab_analysis_slides.pptx
@@ -160,8 +160,8 @@
                         <a:solidFill>
                           <a:srgbClr val="1A1A1A"/>
                         </a:solidFill>
-                        <a:latin typeface="Meiryo"/>
-                        <a:ea typeface="Meiryo"/>
+                        <a:latin typeface="Arial"/>
+                        <a:ea typeface="ＭＳ Ｐゴシック"/>
                       </a:rPr>
                       <a:t>26/33</a:t>
                     </a:r>
@@ -175,8 +175,8 @@
                         <a:solidFill>
                           <a:srgbClr val="1A1A1A"/>
                         </a:solidFill>
-                        <a:latin typeface="Meiryo"/>
-                        <a:ea typeface="Meiryo"/>
+                        <a:latin typeface="Arial"/>
+                        <a:ea typeface="ＭＳ Ｐゴシック"/>
                       </a:rPr>
                       <a:t>(78.8%)</a:t>
                     </a:r>
@@ -204,10 +204,10 @@
                     <a:r>
                       <a:rPr lang="ja-JP" sz="1200" b="1">
                         <a:solidFill>
-                          <a:srgbClr val="1A1A1A"/>
+                          <a:srgbClr val="FF0000"/>
                         </a:solidFill>
-                        <a:latin typeface="Meiryo"/>
-                        <a:ea typeface="Meiryo"/>
+                        <a:latin typeface="Arial"/>
+                        <a:ea typeface="ＭＳ Ｐゴシック"/>
                       </a:rPr>
                       <a:t>32/33</a:t>
                     </a:r>
@@ -219,10 +219,10 @@
                     <a:r>
                       <a:rPr lang="ja-JP" sz="1100" b="0">
                         <a:solidFill>
-                          <a:srgbClr val="1A1A1A"/>
+                          <a:srgbClr val="FF0000"/>
                         </a:solidFill>
-                        <a:latin typeface="Meiryo"/>
-                        <a:ea typeface="Meiryo"/>
+                        <a:latin typeface="Arial"/>
+                        <a:ea typeface="ＭＳ Ｐゴシック"/>
                       </a:rPr>
                       <a:t>(97.0%)</a:t>
                     </a:r>
@@ -247,7 +247,7 @@
                     <a:solidFill>
                       <a:srgbClr val="1A1A1A"/>
                     </a:solidFill>
-                    <a:latin typeface="Meiryo"/>
+                    <a:latin typeface="ＭＳ Ｐゴシック"/>
                   </a:defRPr>
                 </a:pPr>
               </a:p>
@@ -329,8 +329,8 @@
                         <a:solidFill>
                           <a:srgbClr val="1A1A1A"/>
                         </a:solidFill>
-                        <a:latin typeface="Meiryo"/>
-                        <a:ea typeface="Meiryo"/>
+                        <a:latin typeface="Arial"/>
+                        <a:ea typeface="ＭＳ Ｐゴシック"/>
                       </a:rPr>
                       <a:t>7/33</a:t>
                     </a:r>
@@ -344,8 +344,8 @@
                         <a:solidFill>
                           <a:srgbClr val="1A1A1A"/>
                         </a:solidFill>
-                        <a:latin typeface="Meiryo"/>
-                        <a:ea typeface="Meiryo"/>
+                        <a:latin typeface="Arial"/>
+                        <a:ea typeface="ＭＳ Ｐゴシック"/>
                       </a:rPr>
                       <a:t>(21.2%)</a:t>
                     </a:r>
@@ -375,8 +375,8 @@
                         <a:solidFill>
                           <a:srgbClr val="1A1A1A"/>
                         </a:solidFill>
-                        <a:latin typeface="Meiryo"/>
-                        <a:ea typeface="Meiryo"/>
+                        <a:latin typeface="Arial"/>
+                        <a:ea typeface="ＭＳ Ｐゴシック"/>
                       </a:rPr>
                       <a:t>1/33</a:t>
                     </a:r>
@@ -390,8 +390,8 @@
                         <a:solidFill>
                           <a:srgbClr val="1A1A1A"/>
                         </a:solidFill>
-                        <a:latin typeface="Meiryo"/>
-                        <a:ea typeface="Meiryo"/>
+                        <a:latin typeface="Arial"/>
+                        <a:ea typeface="ＭＳ Ｐゴシック"/>
                       </a:rPr>
                       <a:t>(3.0%)</a:t>
                     </a:r>
@@ -416,7 +416,7 @@
                     <a:solidFill>
                       <a:srgbClr val="1A1A1A"/>
                     </a:solidFill>
-                    <a:latin typeface="Meiryo"/>
+                    <a:latin typeface="ＭＳ Ｐゴシック"/>
                   </a:defRPr>
                 </a:pPr>
               </a:p>
@@ -472,7 +472,7 @@
                   <a:solidFill>
                     <a:srgbClr val="1A1A1A"/>
                   </a:solidFill>
-                  <a:latin typeface="Meiryo"/>
+                  <a:latin typeface="ＭＳ Ｐゴシック"/>
                 </a:defRPr>
               </a:pPr>
             </a:p>
@@ -520,7 +520,7 @@
                 <a:solidFill>
                   <a:srgbClr val="1A1A1A"/>
                 </a:solidFill>
-                <a:latin typeface="Meiryo"/>
+                <a:latin typeface="ＭＳ Ｐゴシック"/>
               </a:defRPr>
             </a:pPr>
             <a:endParaRPr lang="en-US"/>
@@ -574,7 +574,7 @@
                 <a:solidFill>
                   <a:srgbClr val="666666"/>
                 </a:solidFill>
-                <a:latin typeface="Meiryo"/>
+                <a:latin typeface="ＭＳ Ｐゴシック"/>
               </a:defRPr>
             </a:pPr>
             <a:endParaRPr lang="en-US"/>
@@ -605,8 +605,8 @@
               <a:solidFill>
                 <a:srgbClr val="333333"/>
               </a:solidFill>
-              <a:latin typeface="Meiryo"/>
-              <a:cs typeface="Meiryo"/>
+              <a:latin typeface="ＭＳ Ｐゴシック"/>
+              <a:cs typeface="ＭＳ Ｐゴシック"/>
             </a:defRPr>
           </a:pPr>
           <a:endParaRPr lang="en-US"/>
@@ -678,8 +678,8 @@
                         <a:solidFill>
                           <a:srgbClr val="1A1A1A"/>
                         </a:solidFill>
-                        <a:latin typeface="Meiryo"/>
-                        <a:ea typeface="Meiryo"/>
+                        <a:latin typeface="Arial"/>
+                        <a:ea typeface="ＭＳ Ｐゴシック"/>
                       </a:rPr>
                       <a:t>0.00</a:t>
                     </a:r>
@@ -693,8 +693,8 @@
                         <a:solidFill>
                           <a:srgbClr val="1A1A1A"/>
                         </a:solidFill>
-                        <a:latin typeface="Meiryo"/>
-                        <a:ea typeface="Meiryo"/>
+                        <a:latin typeface="Arial"/>
+                        <a:ea typeface="ＭＳ Ｐゴシック"/>
                       </a:rPr>
                       <a:t>(n=66)</a:t>
                     </a:r>
@@ -724,8 +724,8 @@
                         <a:solidFill>
                           <a:srgbClr val="1A1A1A"/>
                         </a:solidFill>
-                        <a:latin typeface="Meiryo"/>
-                        <a:ea typeface="Meiryo"/>
+                        <a:latin typeface="Arial"/>
+                        <a:ea typeface="ＭＳ Ｐゴシック"/>
                       </a:rPr>
                       <a:t>0.00</a:t>
                     </a:r>
@@ -739,8 +739,8 @@
                         <a:solidFill>
                           <a:srgbClr val="1A1A1A"/>
                         </a:solidFill>
-                        <a:latin typeface="Meiryo"/>
-                        <a:ea typeface="Meiryo"/>
+                        <a:latin typeface="Arial"/>
+                        <a:ea typeface="ＭＳ Ｐゴシック"/>
                       </a:rPr>
                       <a:t>(n=61)</a:t>
                     </a:r>
@@ -770,8 +770,8 @@
                         <a:solidFill>
                           <a:srgbClr val="1A1A1A"/>
                         </a:solidFill>
-                        <a:latin typeface="Meiryo"/>
-                        <a:ea typeface="Meiryo"/>
+                        <a:latin typeface="Arial"/>
+                        <a:ea typeface="ＭＳ Ｐゴシック"/>
                       </a:rPr>
                       <a:t>-0.35</a:t>
                     </a:r>
@@ -785,8 +785,8 @@
                         <a:solidFill>
                           <a:srgbClr val="1A1A1A"/>
                         </a:solidFill>
-                        <a:latin typeface="Meiryo"/>
-                        <a:ea typeface="Meiryo"/>
+                        <a:latin typeface="Arial"/>
+                        <a:ea typeface="ＭＳ Ｐゴシック"/>
                       </a:rPr>
                       <a:t>(n=49)</a:t>
                     </a:r>
@@ -814,10 +814,10 @@
                     <a:r>
                       <a:rPr lang="ja-JP" sz="1100" b="1">
                         <a:solidFill>
-                          <a:srgbClr val="1A1A1A"/>
+                          <a:srgbClr val="FF0000"/>
                         </a:solidFill>
-                        <a:latin typeface="Meiryo"/>
-                        <a:ea typeface="Meiryo"/>
+                        <a:latin typeface="Arial"/>
+                        <a:ea typeface="ＭＳ Ｐゴシック"/>
                       </a:rPr>
                       <a:t>-1.24</a:t>
                     </a:r>
@@ -829,10 +829,10 @@
                     <a:r>
                       <a:rPr lang="ja-JP" sz="1000" b="0">
                         <a:solidFill>
-                          <a:srgbClr val="1A1A1A"/>
+                          <a:srgbClr val="FF0000"/>
                         </a:solidFill>
-                        <a:latin typeface="Meiryo"/>
-                        <a:ea typeface="Meiryo"/>
+                        <a:latin typeface="Arial"/>
+                        <a:ea typeface="ＭＳ Ｐゴシック"/>
                       </a:rPr>
                       <a:t>(n=33)</a:t>
                     </a:r>
@@ -862,8 +862,8 @@
                         <a:solidFill>
                           <a:srgbClr val="1A1A1A"/>
                         </a:solidFill>
-                        <a:latin typeface="Meiryo"/>
-                        <a:ea typeface="Meiryo"/>
+                        <a:latin typeface="Arial"/>
+                        <a:ea typeface="ＭＳ Ｐゴシック"/>
                       </a:rPr>
                       <a:t>-1.75</a:t>
                     </a:r>
@@ -877,8 +877,8 @@
                         <a:solidFill>
                           <a:srgbClr val="1A1A1A"/>
                         </a:solidFill>
-                        <a:latin typeface="Meiryo"/>
-                        <a:ea typeface="Meiryo"/>
+                        <a:latin typeface="Arial"/>
+                        <a:ea typeface="ＭＳ Ｐゴシック"/>
                       </a:rPr>
                       <a:t>(n=16)</a:t>
                     </a:r>
@@ -903,7 +903,7 @@
                     <a:solidFill>
                       <a:srgbClr val="1A1A1A"/>
                     </a:solidFill>
-                    <a:latin typeface="Meiryo"/>
+                    <a:latin typeface="ＭＳ Ｐゴシック"/>
                   </a:defRPr>
                 </a:pPr>
               </a:p>
@@ -977,7 +977,7 @@
                   <a:solidFill>
                     <a:srgbClr val="1A1A1A"/>
                   </a:solidFill>
-                  <a:latin typeface="Meiryo"/>
+                  <a:latin typeface="ＭＳ Ｐゴシック"/>
                 </a:defRPr>
               </a:pPr>
             </a:p>
@@ -1025,7 +1025,7 @@
                 <a:solidFill>
                   <a:srgbClr val="1A1A1A"/>
                 </a:solidFill>
-                <a:latin typeface="Meiryo"/>
+                <a:latin typeface="ＭＳ Ｐゴシック"/>
               </a:defRPr>
             </a:pPr>
             <a:endParaRPr lang="en-US"/>
@@ -1079,7 +1079,7 @@
                 <a:solidFill>
                   <a:srgbClr val="666666"/>
                 </a:solidFill>
-                <a:latin typeface="Meiryo"/>
+                <a:latin typeface="ＭＳ Ｐゴシック"/>
               </a:defRPr>
             </a:pPr>
             <a:endParaRPr lang="en-US"/>
@@ -1163,8 +1163,8 @@
                         <a:solidFill>
                           <a:srgbClr val="1A1A1A"/>
                         </a:solidFill>
-                        <a:latin typeface="Meiryo"/>
-                        <a:ea typeface="Meiryo"/>
+                        <a:latin typeface="Arial"/>
+                        <a:ea typeface="ＭＳ Ｐゴシック"/>
                       </a:rPr>
                       <a:t>13例</a:t>
                     </a:r>
@@ -1178,8 +1178,8 @@
                         <a:solidFill>
                           <a:srgbClr val="1A1A1A"/>
                         </a:solidFill>
-                        <a:latin typeface="Meiryo"/>
-                        <a:ea typeface="Meiryo"/>
+                        <a:latin typeface="Arial"/>
+                        <a:ea typeface="ＭＳ Ｐゴシック"/>
                       </a:rPr>
                       <a:t>(39.4%)</a:t>
                     </a:r>
@@ -1209,8 +1209,8 @@
                         <a:solidFill>
                           <a:srgbClr val="1A1A1A"/>
                         </a:solidFill>
-                        <a:latin typeface="Meiryo"/>
-                        <a:ea typeface="Meiryo"/>
+                        <a:latin typeface="Arial"/>
+                        <a:ea typeface="ＭＳ Ｐゴシック"/>
                       </a:rPr>
                       <a:t>4例</a:t>
                     </a:r>
@@ -1224,8 +1224,8 @@
                         <a:solidFill>
                           <a:srgbClr val="1A1A1A"/>
                         </a:solidFill>
-                        <a:latin typeface="Meiryo"/>
-                        <a:ea typeface="Meiryo"/>
+                        <a:latin typeface="Arial"/>
+                        <a:ea typeface="ＭＳ Ｐゴシック"/>
                       </a:rPr>
                       <a:t>(12.1%)</a:t>
                     </a:r>
@@ -1253,10 +1253,10 @@
                     <a:r>
                       <a:rPr lang="ja-JP" sz="1200" b="1">
                         <a:solidFill>
-                          <a:srgbClr val="1A1A1A"/>
+                          <a:srgbClr val="FF0000"/>
                         </a:solidFill>
-                        <a:latin typeface="Meiryo"/>
-                        <a:ea typeface="Meiryo"/>
+                        <a:latin typeface="Arial"/>
+                        <a:ea typeface="ＭＳ Ｐゴシック"/>
                       </a:rPr>
                       <a:t>16例</a:t>
                     </a:r>
@@ -1268,10 +1268,10 @@
                     <a:r>
                       <a:rPr lang="ja-JP" sz="1100" b="0">
                         <a:solidFill>
-                          <a:srgbClr val="1A1A1A"/>
+                          <a:srgbClr val="FF0000"/>
                         </a:solidFill>
-                        <a:latin typeface="Meiryo"/>
-                        <a:ea typeface="Meiryo"/>
+                        <a:latin typeface="Arial"/>
+                        <a:ea typeface="ＭＳ Ｐゴシック"/>
                       </a:rPr>
                       <a:t>(48.5%)</a:t>
                     </a:r>
@@ -1296,7 +1296,7 @@
                     <a:solidFill>
                       <a:srgbClr val="1A1A1A"/>
                     </a:solidFill>
-                    <a:latin typeface="Meiryo"/>
+                    <a:latin typeface="ＭＳ Ｐゴシック"/>
                   </a:defRPr>
                 </a:pPr>
               </a:p>
@@ -1394,7 +1394,7 @@
                   <a:solidFill>
                     <a:srgbClr val="1A1A1A"/>
                   </a:solidFill>
-                  <a:latin typeface="Meiryo"/>
+                  <a:latin typeface="ＭＳ Ｐゴシック"/>
                 </a:defRPr>
               </a:pPr>
             </a:p>
@@ -1442,7 +1442,7 @@
                 <a:solidFill>
                   <a:srgbClr val="1A1A1A"/>
                 </a:solidFill>
-                <a:latin typeface="Meiryo"/>
+                <a:latin typeface="ＭＳ Ｐゴシック"/>
               </a:defRPr>
             </a:pPr>
             <a:endParaRPr lang="en-US"/>
@@ -1496,7 +1496,7 @@
                 <a:solidFill>
                   <a:srgbClr val="666666"/>
                 </a:solidFill>
-                <a:latin typeface="Meiryo"/>
+                <a:latin typeface="ＭＳ Ｐゴシック"/>
               </a:defRPr>
             </a:pPr>
             <a:endParaRPr lang="en-US"/>
@@ -1578,10 +1578,10 @@
                     <a:r>
                       <a:rPr lang="ja-JP" sz="1300" b="1">
                         <a:solidFill>
-                          <a:srgbClr val="1A1A1A"/>
+                          <a:srgbClr val="FF0000"/>
                         </a:solidFill>
-                        <a:latin typeface="Meiryo"/>
-                        <a:ea typeface="Meiryo"/>
+                        <a:latin typeface="Arial"/>
+                        <a:ea typeface="ＭＳ Ｐゴシック"/>
                       </a:rPr>
                       <a:t>17例</a:t>
                     </a:r>
@@ -1593,10 +1593,10 @@
                     <a:r>
                       <a:rPr lang="ja-JP" sz="1200" b="0">
                         <a:solidFill>
-                          <a:srgbClr val="1A1A1A"/>
+                          <a:srgbClr val="FF0000"/>
                         </a:solidFill>
-                        <a:latin typeface="Meiryo"/>
-                        <a:ea typeface="Meiryo"/>
+                        <a:latin typeface="Arial"/>
+                        <a:ea typeface="ＭＳ Ｐゴシック"/>
                       </a:rPr>
                       <a:t>(25.8%)</a:t>
                     </a:r>
@@ -1626,8 +1626,8 @@
                         <a:solidFill>
                           <a:srgbClr val="1A1A1A"/>
                         </a:solidFill>
-                        <a:latin typeface="Meiryo"/>
-                        <a:ea typeface="Meiryo"/>
+                        <a:latin typeface="Arial"/>
+                        <a:ea typeface="ＭＳ Ｐゴシック"/>
                       </a:rPr>
                       <a:t>49例</a:t>
                     </a:r>
@@ -1641,8 +1641,8 @@
                         <a:solidFill>
                           <a:srgbClr val="1A1A1A"/>
                         </a:solidFill>
-                        <a:latin typeface="Meiryo"/>
-                        <a:ea typeface="Meiryo"/>
+                        <a:latin typeface="Arial"/>
+                        <a:ea typeface="ＭＳ Ｐゴシック"/>
                       </a:rPr>
                       <a:t>(74.2%)</a:t>
                     </a:r>
@@ -1667,7 +1667,7 @@
                     <a:solidFill>
                       <a:srgbClr val="1A1A1A"/>
                     </a:solidFill>
-                    <a:latin typeface="Meiryo"/>
+                    <a:latin typeface="ＭＳ Ｐゴシック"/>
                   </a:defRPr>
                 </a:pPr>
               </a:p>
@@ -1745,7 +1745,7 @@
                   <a:solidFill>
                     <a:srgbClr val="1A1A1A"/>
                   </a:solidFill>
-                  <a:latin typeface="Meiryo"/>
+                  <a:latin typeface="ＭＳ Ｐゴシック"/>
                 </a:defRPr>
               </a:pPr>
             </a:p>
@@ -1793,7 +1793,7 @@
                 <a:solidFill>
                   <a:srgbClr val="1A1A1A"/>
                 </a:solidFill>
-                <a:latin typeface="Meiryo"/>
+                <a:latin typeface="ＭＳ Ｐゴシック"/>
               </a:defRPr>
             </a:pPr>
             <a:endParaRPr lang="en-US"/>
@@ -1847,7 +1847,7 @@
                 <a:solidFill>
                   <a:srgbClr val="666666"/>
                 </a:solidFill>
-                <a:latin typeface="Meiryo"/>
+                <a:latin typeface="ＭＳ Ｐゴシック"/>
               </a:defRPr>
             </a:pPr>
             <a:endParaRPr lang="en-US"/>
@@ -1916,6 +1916,68 @@
           </c:spPr>
           <c:invertIfNegative val="0"/>
           <c:dLbls>
+            <c:dLbl>
+              <c:idx val="0"/>
+              <c:tx>
+                <c:rich>
+                  <a:bodyPr wrap="square" lIns="0" tIns="0" rIns="0" bIns="0" anchor="ctr"/>
+                  <a:lstStyle/>
+                  <a:p>
+                    <a:pPr algn="ctr">
+                      <a:defRPr sz="1400"/>
+                    </a:pPr>
+                    <a:r>
+                      <a:rPr lang="ja-JP" sz="1400" b="1">
+                        <a:solidFill>
+                          <a:srgbClr val="FF0000"/>
+                        </a:solidFill>
+                        <a:latin typeface="Arial"/>
+                        <a:ea typeface="ＭＳ Ｐゴシック"/>
+                      </a:rPr>
+                      <a:t>+0.22</a:t>
+                    </a:r>
+                  </a:p>
+                </c:rich>
+              </c:tx>
+              <c:dLblPos val="outEnd"/>
+              <c:showLegendKey val="0"/>
+              <c:showVal val="0"/>
+              <c:showCatName val="0"/>
+              <c:showSerName val="0"/>
+              <c:showPercent val="0"/>
+              <c:showBubbleSize val="0"/>
+            </c:dLbl>
+            <c:dLbl>
+              <c:idx val="1"/>
+              <c:tx>
+                <c:rich>
+                  <a:bodyPr wrap="square" lIns="0" tIns="0" rIns="0" bIns="0" anchor="ctr"/>
+                  <a:lstStyle/>
+                  <a:p>
+                    <a:pPr algn="ctr">
+                      <a:defRPr sz="1400"/>
+                    </a:pPr>
+                    <a:r>
+                      <a:rPr lang="ja-JP" sz="1400" b="1">
+                        <a:solidFill>
+                          <a:srgbClr val="1A1A1A"/>
+                        </a:solidFill>
+                        <a:latin typeface="Arial"/>
+                        <a:ea typeface="ＭＳ Ｐゴシック"/>
+                      </a:rPr>
+                      <a:t>-1.79</a:t>
+                    </a:r>
+                  </a:p>
+                </c:rich>
+              </c:tx>
+              <c:dLblPos val="outEnd"/>
+              <c:showLegendKey val="0"/>
+              <c:showVal val="0"/>
+              <c:showCatName val="0"/>
+              <c:showSerName val="0"/>
+              <c:showPercent val="0"/>
+              <c:showBubbleSize val="0"/>
+            </c:dLbl>
             <c:numFmt formatCode="+0.00;-0.00;0.00" sourceLinked="0"/>
             <c:txPr>
               <a:bodyPr/>
@@ -1926,7 +1988,7 @@
                     <a:solidFill>
                       <a:srgbClr val="1A1A1A"/>
                     </a:solidFill>
-                    <a:latin typeface="Meiryo"/>
+                    <a:latin typeface="ＭＳ Ｐゴシック"/>
                   </a:defRPr>
                 </a:pPr>
               </a:p>
@@ -2006,7 +2068,7 @@
                   <a:solidFill>
                     <a:srgbClr val="1A1A1A"/>
                   </a:solidFill>
-                  <a:latin typeface="Meiryo"/>
+                  <a:latin typeface="ＭＳ Ｐゴシック"/>
                 </a:defRPr>
               </a:pPr>
             </a:p>
@@ -2054,7 +2116,7 @@
                 <a:solidFill>
                   <a:srgbClr val="1A1A1A"/>
                 </a:solidFill>
-                <a:latin typeface="Meiryo"/>
+                <a:latin typeface="ＭＳ Ｐゴシック"/>
               </a:defRPr>
             </a:pPr>
             <a:endParaRPr lang="en-US"/>
@@ -2108,7 +2170,7 @@
                 <a:solidFill>
                   <a:srgbClr val="666666"/>
                 </a:solidFill>
-                <a:latin typeface="Meiryo"/>
+                <a:latin typeface="ＭＳ Ｐゴシック"/>
               </a:defRPr>
             </a:pPr>
             <a:endParaRPr lang="en-US"/>
@@ -2197,8 +2259,8 @@
                         <a:solidFill>
                           <a:srgbClr val="1A1A1A"/>
                         </a:solidFill>
-                        <a:latin typeface="Meiryo"/>
-                        <a:ea typeface="Meiryo"/>
+                        <a:latin typeface="Arial"/>
+                        <a:ea typeface="ＭＳ Ｐゴシック"/>
                       </a:rPr>
                       <a:t>+1.38</a:t>
                     </a:r>
@@ -2212,8 +2274,8 @@
                         <a:solidFill>
                           <a:srgbClr val="1A1A1A"/>
                         </a:solidFill>
-                        <a:latin typeface="Meiryo"/>
-                        <a:ea typeface="Meiryo"/>
+                        <a:latin typeface="Arial"/>
+                        <a:ea typeface="ＭＳ Ｐゴシック"/>
                       </a:rPr>
                       <a:t>(n=16)</a:t>
                     </a:r>
@@ -2243,8 +2305,8 @@
                         <a:solidFill>
                           <a:srgbClr val="1A1A1A"/>
                         </a:solidFill>
-                        <a:latin typeface="Meiryo"/>
-                        <a:ea typeface="Meiryo"/>
+                        <a:latin typeface="Arial"/>
+                        <a:ea typeface="ＭＳ Ｐゴシック"/>
                       </a:rPr>
                       <a:t>+0.33</a:t>
                     </a:r>
@@ -2258,8 +2320,8 @@
                         <a:solidFill>
                           <a:srgbClr val="1A1A1A"/>
                         </a:solidFill>
-                        <a:latin typeface="Meiryo"/>
-                        <a:ea typeface="Meiryo"/>
+                        <a:latin typeface="Arial"/>
+                        <a:ea typeface="ＭＳ Ｐゴシック"/>
                       </a:rPr>
                       <a:t>(n=12)</a:t>
                     </a:r>
@@ -2289,8 +2351,8 @@
                         <a:solidFill>
                           <a:srgbClr val="1A1A1A"/>
                         </a:solidFill>
-                        <a:latin typeface="Meiryo"/>
-                        <a:ea typeface="Meiryo"/>
+                        <a:latin typeface="Arial"/>
+                        <a:ea typeface="ＭＳ Ｐゴシック"/>
                       </a:rPr>
                       <a:t>+0.22</a:t>
                     </a:r>
@@ -2304,8 +2366,8 @@
                         <a:solidFill>
                           <a:srgbClr val="1A1A1A"/>
                         </a:solidFill>
-                        <a:latin typeface="Meiryo"/>
-                        <a:ea typeface="Meiryo"/>
+                        <a:latin typeface="Arial"/>
+                        <a:ea typeface="ＭＳ Ｐゴシック"/>
                       </a:rPr>
                       <a:t>(n=9)</a:t>
                     </a:r>
@@ -2335,8 +2397,8 @@
                         <a:solidFill>
                           <a:srgbClr val="1A1A1A"/>
                         </a:solidFill>
-                        <a:latin typeface="Meiryo"/>
-                        <a:ea typeface="Meiryo"/>
+                        <a:latin typeface="Arial"/>
+                        <a:ea typeface="ＭＳ Ｐゴシック"/>
                       </a:rPr>
                       <a:t>-0.17</a:t>
                     </a:r>
@@ -2350,8 +2412,8 @@
                         <a:solidFill>
                           <a:srgbClr val="1A1A1A"/>
                         </a:solidFill>
-                        <a:latin typeface="Meiryo"/>
-                        <a:ea typeface="Meiryo"/>
+                        <a:latin typeface="Arial"/>
+                        <a:ea typeface="ＭＳ Ｐゴシック"/>
                       </a:rPr>
                       <a:t>(n=6)</a:t>
                     </a:r>
@@ -2376,7 +2438,7 @@
                     <a:solidFill>
                       <a:srgbClr val="1A1A1A"/>
                     </a:solidFill>
-                    <a:latin typeface="Meiryo"/>
+                    <a:latin typeface="ＭＳ Ｐゴシック"/>
                   </a:defRPr>
                 </a:pPr>
               </a:p>
@@ -2496,8 +2558,8 @@
                         <a:solidFill>
                           <a:srgbClr val="1A1A1A"/>
                         </a:solidFill>
-                        <a:latin typeface="Meiryo"/>
-                        <a:ea typeface="Meiryo"/>
+                        <a:latin typeface="Arial"/>
+                        <a:ea typeface="ＭＳ Ｐゴシック"/>
                       </a:rPr>
                       <a:t>-0.49</a:t>
                     </a:r>
@@ -2511,8 +2573,8 @@
                         <a:solidFill>
                           <a:srgbClr val="1A1A1A"/>
                         </a:solidFill>
-                        <a:latin typeface="Meiryo"/>
-                        <a:ea typeface="Meiryo"/>
+                        <a:latin typeface="Arial"/>
+                        <a:ea typeface="ＭＳ Ｐゴシック"/>
                       </a:rPr>
                       <a:t>(n=45)</a:t>
                     </a:r>
@@ -2542,8 +2604,8 @@
                         <a:solidFill>
                           <a:srgbClr val="1A1A1A"/>
                         </a:solidFill>
-                        <a:latin typeface="Meiryo"/>
-                        <a:ea typeface="Meiryo"/>
+                        <a:latin typeface="Arial"/>
+                        <a:ea typeface="ＭＳ Ｐゴシック"/>
                       </a:rPr>
                       <a:t>-0.57</a:t>
                     </a:r>
@@ -2557,8 +2619,8 @@
                         <a:solidFill>
                           <a:srgbClr val="1A1A1A"/>
                         </a:solidFill>
-                        <a:latin typeface="Meiryo"/>
-                        <a:ea typeface="Meiryo"/>
+                        <a:latin typeface="Arial"/>
+                        <a:ea typeface="ＭＳ Ｐゴシック"/>
                       </a:rPr>
                       <a:t>(n=37)</a:t>
                     </a:r>
@@ -2588,8 +2650,8 @@
                         <a:solidFill>
                           <a:srgbClr val="1A1A1A"/>
                         </a:solidFill>
-                        <a:latin typeface="Meiryo"/>
-                        <a:ea typeface="Meiryo"/>
+                        <a:latin typeface="Arial"/>
+                        <a:ea typeface="ＭＳ Ｐゴシック"/>
                       </a:rPr>
                       <a:t>-1.79</a:t>
                     </a:r>
@@ -2603,8 +2665,8 @@
                         <a:solidFill>
                           <a:srgbClr val="1A1A1A"/>
                         </a:solidFill>
-                        <a:latin typeface="Meiryo"/>
-                        <a:ea typeface="Meiryo"/>
+                        <a:latin typeface="Arial"/>
+                        <a:ea typeface="ＭＳ Ｐゴシック"/>
                       </a:rPr>
                       <a:t>(n=24)</a:t>
                     </a:r>
@@ -2634,8 +2696,8 @@
                         <a:solidFill>
                           <a:srgbClr val="1A1A1A"/>
                         </a:solidFill>
-                        <a:latin typeface="Meiryo"/>
-                        <a:ea typeface="Meiryo"/>
+                        <a:latin typeface="Arial"/>
+                        <a:ea typeface="ＭＳ Ｐゴシック"/>
                       </a:rPr>
                       <a:t>-2.70</a:t>
                     </a:r>
@@ -2649,8 +2711,8 @@
                         <a:solidFill>
                           <a:srgbClr val="1A1A1A"/>
                         </a:solidFill>
-                        <a:latin typeface="Meiryo"/>
-                        <a:ea typeface="Meiryo"/>
+                        <a:latin typeface="Arial"/>
+                        <a:ea typeface="ＭＳ Ｐゴシック"/>
                       </a:rPr>
                       <a:t>(n=10)</a:t>
                     </a:r>
@@ -2675,7 +2737,7 @@
                     <a:solidFill>
                       <a:srgbClr val="1A1A1A"/>
                     </a:solidFill>
-                    <a:latin typeface="Meiryo"/>
+                    <a:latin typeface="ＭＳ Ｐゴシック"/>
                   </a:defRPr>
                 </a:pPr>
               </a:p>
@@ -2762,7 +2824,7 @@
                   <a:solidFill>
                     <a:srgbClr val="1A1A1A"/>
                   </a:solidFill>
-                  <a:latin typeface="Meiryo"/>
+                  <a:latin typeface="ＭＳ Ｐゴシック"/>
                 </a:defRPr>
               </a:pPr>
             </a:p>
@@ -2810,7 +2872,7 @@
                 <a:solidFill>
                   <a:srgbClr val="1A1A1A"/>
                 </a:solidFill>
-                <a:latin typeface="Meiryo"/>
+                <a:latin typeface="ＭＳ Ｐゴシック"/>
               </a:defRPr>
             </a:pPr>
             <a:endParaRPr lang="en-US"/>
@@ -2864,7 +2926,7 @@
                 <a:solidFill>
                   <a:srgbClr val="666666"/>
                 </a:solidFill>
-                <a:latin typeface="Meiryo"/>
+                <a:latin typeface="ＭＳ Ｐゴシック"/>
               </a:defRPr>
             </a:pPr>
             <a:endParaRPr lang="en-US"/>
@@ -2895,8 +2957,8 @@
               <a:solidFill>
                 <a:srgbClr val="333333"/>
               </a:solidFill>
-              <a:latin typeface="Meiryo"/>
-              <a:cs typeface="Meiryo"/>
+              <a:latin typeface="ＭＳ Ｐゴシック"/>
+              <a:cs typeface="ＭＳ Ｐゴシック"/>
             </a:defRPr>
           </a:pPr>
           <a:endParaRPr lang="en-US"/>
@@ -4068,9 +4130,9 @@
                 <a:solidFill>
                   <a:srgbClr val="1A1A1A"/>
                 </a:solidFill>
-                <a:latin typeface="Meiryo" pitchFamily="34" charset="0"/>
-                <a:ea typeface="Meiryo" pitchFamily="34" charset="-122"/>
-                <a:cs typeface="Meiryo" pitchFamily="34" charset="-120"/>
+                <a:latin typeface="Arial" pitchFamily="34" charset="0"/>
+                <a:ea typeface="ＭＳ Ｐゴシック" pitchFamily="34" charset="-122"/>
+                <a:cs typeface="Arial" pitchFamily="34" charset="-120"/>
               </a:rPr>
               <a:t>遅延再生低下例の割合：0か月から18か月の変化</a:t>
             </a:r>
@@ -4107,9 +4169,9 @@
                 <a:solidFill>
                   <a:srgbClr val="666666"/>
                 </a:solidFill>
-                <a:latin typeface="Meiryo" pitchFamily="34" charset="0"/>
-                <a:ea typeface="Meiryo" pitchFamily="34" charset="-122"/>
-                <a:cs typeface="Meiryo" pitchFamily="34" charset="-120"/>
+                <a:latin typeface="Arial" pitchFamily="34" charset="0"/>
+                <a:ea typeface="ＭＳ Ｐゴシック" pitchFamily="34" charset="-122"/>
+                <a:cs typeface="Arial" pitchFamily="34" charset="-120"/>
               </a:rPr>
               <a:t>対象：0か月・18か月の両時点で評価できた33例</a:t>
             </a:r>
@@ -4120,6 +4182,29 @@
       <p:sp>
         <p:nvSpPr>
           <p:cNvPr id="4" name="Shape 2"/>
+          <p:cNvSpPr/>
+          <p:nvPr/>
+        </p:nvSpPr>
+        <p:spPr>
+          <a:xfrm>
+            <a:off x="457200" y="1207008"/>
+            <a:ext cx="11277295" cy="0"/>
+          </a:xfrm>
+          <a:prstGeom prst="line">
+            <a:avLst/>
+          </a:prstGeom>
+          <a:noFill/>
+          <a:ln w="22225">
+            <a:solidFill>
+              <a:srgbClr val="156082"/>
+            </a:solidFill>
+            <a:prstDash val="solid"/>
+          </a:ln>
+        </p:spPr>
+      </p:sp>
+      <p:sp>
+        <p:nvSpPr>
+          <p:cNvPr id="5" name="Shape 3"/>
           <p:cNvSpPr/>
           <p:nvPr/>
         </p:nvSpPr>
@@ -4146,7 +4231,7 @@
       </p:sp>
       <p:sp>
         <p:nvSpPr>
-          <p:cNvPr id="5" name="Text 3"/>
+          <p:cNvPr id="6" name="Text 4"/>
           <p:cNvSpPr/>
           <p:nvPr/>
         </p:nvSpPr>
@@ -4176,9 +4261,9 @@
                 <a:solidFill>
                   <a:srgbClr val="333333"/>
                 </a:solidFill>
-                <a:latin typeface="Meiryo" pitchFamily="34" charset="0"/>
-                <a:ea typeface="Meiryo" pitchFamily="34" charset="-122"/>
-                <a:cs typeface="Meiryo" pitchFamily="34" charset="-120"/>
+                <a:latin typeface="Arial" pitchFamily="34" charset="0"/>
+                <a:ea typeface="ＭＳ Ｐゴシック" pitchFamily="34" charset="-122"/>
+                <a:cs typeface="Arial" pitchFamily="34" charset="-120"/>
               </a:rPr>
               <a:t>McNemar正確検定 p = 0.031</a:t>
             </a:r>
@@ -4196,9 +4281,9 @@
                 <a:solidFill>
                   <a:srgbClr val="333333"/>
                 </a:solidFill>
-                <a:latin typeface="Meiryo" pitchFamily="34" charset="0"/>
-                <a:ea typeface="Meiryo" pitchFamily="34" charset="-122"/>
-                <a:cs typeface="Meiryo" pitchFamily="34" charset="-120"/>
+                <a:latin typeface="Arial" pitchFamily="34" charset="0"/>
+                <a:ea typeface="ＭＳ Ｐゴシック" pitchFamily="34" charset="-122"/>
+                <a:cs typeface="Arial" pitchFamily="34" charset="-120"/>
               </a:rPr>
               <a:t>正常→低下：6例、低下→正常：0例</a:t>
             </a:r>
@@ -4208,7 +4293,7 @@
       </p:sp>
       <p:graphicFrame>
         <p:nvGraphicFramePr>
-          <p:cNvPr id="6" name="Chart 0" descr=""/>
+          <p:cNvPr id="7" name="Chart 0" descr=""/>
           <p:cNvGraphicFramePr/>
           <p:nvPr/>
         </p:nvGraphicFramePr>
@@ -4332,6 +4417,29 @@
           </a:p>
         </p:txBody>
       </p:sp>
+      <p:sp>
+        <p:nvSpPr>
+          <p:cNvPr id="4" name="Shape 2"/>
+          <p:cNvSpPr/>
+          <p:nvPr/>
+        </p:nvSpPr>
+        <p:spPr>
+          <a:xfrm>
+            <a:off x="457200" y="1261872"/>
+            <a:ext cx="11277295" cy="0"/>
+          </a:xfrm>
+          <a:prstGeom prst="line">
+            <a:avLst/>
+          </a:prstGeom>
+          <a:noFill/>
+          <a:ln w="22225">
+            <a:solidFill>
+              <a:srgbClr val="156082"/>
+            </a:solidFill>
+            <a:prstDash val="solid"/>
+          </a:ln>
+        </p:spPr>
+      </p:sp>
       <p:graphicFrame>
         <p:nvGraphicFramePr>
           <p:cNvPr id="3" name="Table 0"/>
@@ -5618,7 +5726,7 @@
       </p:graphicFrame>
       <p:sp>
         <p:nvSpPr>
-          <p:cNvPr id="5" name="Shape 2"/>
+          <p:cNvPr id="6" name="Shape 3"/>
           <p:cNvSpPr/>
           <p:nvPr/>
         </p:nvSpPr>
@@ -5641,7 +5749,7 @@
       </p:sp>
       <p:sp>
         <p:nvSpPr>
-          <p:cNvPr id="6" name="Shape 3"/>
+          <p:cNvPr id="7" name="Shape 4"/>
           <p:cNvSpPr/>
           <p:nvPr/>
         </p:nvSpPr>
@@ -5664,7 +5772,7 @@
       </p:sp>
       <p:sp>
         <p:nvSpPr>
-          <p:cNvPr id="7" name="Shape 4"/>
+          <p:cNvPr id="8" name="Shape 5"/>
           <p:cNvSpPr/>
           <p:nvPr/>
         </p:nvSpPr>
@@ -5687,7 +5795,7 @@
       </p:sp>
       <p:sp>
         <p:nvSpPr>
-          <p:cNvPr id="8" name="Text 5"/>
+          <p:cNvPr id="9" name="Text 6"/>
           <p:cNvSpPr/>
           <p:nvPr/>
         </p:nvSpPr>
@@ -5788,9 +5896,9 @@
                 <a:solidFill>
                   <a:srgbClr val="1A1A1A"/>
                 </a:solidFill>
-                <a:latin typeface="Meiryo" pitchFamily="34" charset="0"/>
-                <a:ea typeface="Meiryo" pitchFamily="34" charset="-122"/>
-                <a:cs typeface="Meiryo" pitchFamily="34" charset="-120"/>
+                <a:latin typeface="Arial" pitchFamily="34" charset="0"/>
+                <a:ea typeface="ＭＳ Ｐゴシック" pitchFamily="34" charset="-122"/>
+                <a:cs typeface="Arial" pitchFamily="34" charset="-120"/>
               </a:rPr>
               <a:t>レカネマブ投与患者におけるMMSEの推移</a:t>
             </a:r>
@@ -5827,9 +5935,9 @@
                 <a:solidFill>
                   <a:srgbClr val="666666"/>
                 </a:solidFill>
-                <a:latin typeface="Meiryo" pitchFamily="34" charset="0"/>
-                <a:ea typeface="Meiryo" pitchFamily="34" charset="-122"/>
-                <a:cs typeface="Meiryo" pitchFamily="34" charset="-120"/>
+                <a:latin typeface="Arial" pitchFamily="34" charset="0"/>
+                <a:ea typeface="ＭＳ Ｐゴシック" pitchFamily="34" charset="-122"/>
+                <a:cs typeface="Arial" pitchFamily="34" charset="-120"/>
               </a:rPr>
               <a:t>対象：レカネマブ投与患者66例（各時点での評価症例数は図中に記載）</a:t>
             </a:r>
@@ -5839,7 +5947,30 @@
       </p:sp>
       <p:sp>
         <p:nvSpPr>
-          <p:cNvPr id="4" name="Text 2"/>
+          <p:cNvPr id="4" name="Shape 2"/>
+          <p:cNvSpPr/>
+          <p:nvPr/>
+        </p:nvSpPr>
+        <p:spPr>
+          <a:xfrm>
+            <a:off x="457200" y="1207008"/>
+            <a:ext cx="11277295" cy="0"/>
+          </a:xfrm>
+          <a:prstGeom prst="line">
+            <a:avLst/>
+          </a:prstGeom>
+          <a:noFill/>
+          <a:ln w="22225">
+            <a:solidFill>
+              <a:srgbClr val="156082"/>
+            </a:solidFill>
+            <a:prstDash val="solid"/>
+          </a:ln>
+        </p:spPr>
+      </p:sp>
+      <p:sp>
+        <p:nvSpPr>
+          <p:cNvPr id="5" name="Text 3"/>
           <p:cNvSpPr/>
           <p:nvPr/>
         </p:nvSpPr>
@@ -5866,9 +5997,9 @@
                 <a:solidFill>
                   <a:srgbClr val="1A1A1A"/>
                 </a:solidFill>
-                <a:latin typeface="Meiryo" pitchFamily="34" charset="0"/>
-                <a:ea typeface="Meiryo" pitchFamily="34" charset="-122"/>
-                <a:cs typeface="Meiryo" pitchFamily="34" charset="-120"/>
+                <a:latin typeface="Arial" pitchFamily="34" charset="0"/>
+                <a:ea typeface="ＭＳ Ｐゴシック" pitchFamily="34" charset="-122"/>
+                <a:cs typeface="Arial" pitchFamily="34" charset="-120"/>
               </a:rPr>
               <a:t>A. MMSE平均変化量の推移</a:t>
             </a:r>
@@ -5878,7 +6009,7 @@
       </p:sp>
       <p:sp>
         <p:nvSpPr>
-          <p:cNvPr id="5" name="Text 3"/>
+          <p:cNvPr id="6" name="Text 4"/>
           <p:cNvSpPr/>
           <p:nvPr/>
         </p:nvSpPr>
@@ -5905,9 +6036,9 @@
                 <a:solidFill>
                   <a:srgbClr val="1A1A1A"/>
                 </a:solidFill>
-                <a:latin typeface="Meiryo" pitchFamily="34" charset="0"/>
-                <a:ea typeface="Meiryo" pitchFamily="34" charset="-122"/>
-                <a:cs typeface="Meiryo" pitchFamily="34" charset="-120"/>
+                <a:latin typeface="Arial" pitchFamily="34" charset="0"/>
+                <a:ea typeface="ＭＳ Ｐゴシック" pitchFamily="34" charset="-122"/>
+                <a:cs typeface="Arial" pitchFamily="34" charset="-120"/>
               </a:rPr>
               <a:t>B. 18か月時点の変化分類（n=33）</a:t>
             </a:r>
@@ -5917,7 +6048,7 @@
       </p:sp>
       <p:graphicFrame>
         <p:nvGraphicFramePr>
-          <p:cNvPr id="6" name="Chart 0" descr=""/>
+          <p:cNvPr id="7" name="Chart 0" descr=""/>
           <p:cNvGraphicFramePr/>
           <p:nvPr/>
         </p:nvGraphicFramePr>
@@ -5933,7 +6064,7 @@
       </p:graphicFrame>
       <p:graphicFrame>
         <p:nvGraphicFramePr>
-          <p:cNvPr id="7" name="Chart 1" descr=""/>
+          <p:cNvPr id="8" name="Chart 1" descr=""/>
           <p:cNvGraphicFramePr/>
           <p:nvPr/>
         </p:nvGraphicFramePr>
@@ -5949,7 +6080,7 @@
       </p:graphicFrame>
       <p:sp>
         <p:nvSpPr>
-          <p:cNvPr id="8" name="Text 4"/>
+          <p:cNvPr id="9" name="Text 5"/>
           <p:cNvSpPr/>
           <p:nvPr/>
         </p:nvSpPr>
@@ -5979,9 +6110,9 @@
                 <a:solidFill>
                   <a:srgbClr val="666666"/>
                 </a:solidFill>
-                <a:latin typeface="Meiryo" pitchFamily="34" charset="0"/>
-                <a:ea typeface="Meiryo" pitchFamily="34" charset="-122"/>
-                <a:cs typeface="Meiryo" pitchFamily="34" charset="-120"/>
+                <a:latin typeface="Arial" pitchFamily="34" charset="0"/>
+                <a:ea typeface="ＭＳ Ｐゴシック" pitchFamily="34" charset="-122"/>
+                <a:cs typeface="Arial" pitchFamily="34" charset="-120"/>
               </a:rPr>
               <a:t>18か月対応解析：平均変化 −1.24点（0か月23.91点→18か月22.67点）。対応のあるt検定 p=0.087、Wilcoxon符号付順位検定 p=0.188。※24か月は補助データ（n=16）。図中nは各時点での対応症例数。</a:t>
             </a:r>
@@ -6050,9 +6181,9 @@
                 <a:solidFill>
                   <a:srgbClr val="1A1A1A"/>
                 </a:solidFill>
-                <a:latin typeface="Meiryo" pitchFamily="34" charset="0"/>
-                <a:ea typeface="Meiryo" pitchFamily="34" charset="-122"/>
-                <a:cs typeface="Meiryo" pitchFamily="34" charset="-120"/>
+                <a:latin typeface="Arial" pitchFamily="34" charset="0"/>
+                <a:ea typeface="ＭＳ Ｐゴシック" pitchFamily="34" charset="-122"/>
+                <a:cs typeface="Arial" pitchFamily="34" charset="-120"/>
               </a:rPr>
               <a:t>レカネマブ投与後の精神症状（改善訴え）</a:t>
             </a:r>
@@ -6089,9 +6220,9 @@
                 <a:solidFill>
                   <a:srgbClr val="666666"/>
                 </a:solidFill>
-                <a:latin typeface="Meiryo" pitchFamily="34" charset="0"/>
-                <a:ea typeface="Meiryo" pitchFamily="34" charset="-122"/>
-                <a:cs typeface="Meiryo" pitchFamily="34" charset="-120"/>
+                <a:latin typeface="Arial" pitchFamily="34" charset="0"/>
+                <a:ea typeface="ＭＳ Ｐゴシック" pitchFamily="34" charset="-122"/>
+                <a:cs typeface="Arial" pitchFamily="34" charset="-120"/>
               </a:rPr>
               <a:t>対象：レカネマブ投与患者66例</a:t>
             </a:r>
@@ -6102,6 +6233,29 @@
       <p:sp>
         <p:nvSpPr>
           <p:cNvPr id="4" name="Shape 2"/>
+          <p:cNvSpPr/>
+          <p:nvPr/>
+        </p:nvSpPr>
+        <p:spPr>
+          <a:xfrm>
+            <a:off x="457200" y="1207008"/>
+            <a:ext cx="11277295" cy="0"/>
+          </a:xfrm>
+          <a:prstGeom prst="line">
+            <a:avLst/>
+          </a:prstGeom>
+          <a:noFill/>
+          <a:ln w="22225">
+            <a:solidFill>
+              <a:srgbClr val="156082"/>
+            </a:solidFill>
+            <a:prstDash val="solid"/>
+          </a:ln>
+        </p:spPr>
+      </p:sp>
+      <p:sp>
+        <p:nvSpPr>
+          <p:cNvPr id="5" name="Shape 3"/>
           <p:cNvSpPr/>
           <p:nvPr/>
         </p:nvSpPr>
@@ -6128,7 +6282,7 @@
       </p:sp>
       <p:sp>
         <p:nvSpPr>
-          <p:cNvPr id="5" name="Text 3"/>
+          <p:cNvPr id="6" name="Text 4"/>
           <p:cNvSpPr/>
           <p:nvPr/>
         </p:nvSpPr>
@@ -6158,9 +6312,9 @@
                 <a:solidFill>
                   <a:srgbClr val="333333"/>
                 </a:solidFill>
-                <a:latin typeface="Meiryo" pitchFamily="34" charset="0"/>
-                <a:ea typeface="Meiryo" pitchFamily="34" charset="-122"/>
-                <a:cs typeface="Meiryo" pitchFamily="34" charset="-120"/>
+                <a:latin typeface="Arial" pitchFamily="34" charset="0"/>
+                <a:ea typeface="ＭＳ Ｐゴシック" pitchFamily="34" charset="-122"/>
+                <a:cs typeface="Arial" pitchFamily="34" charset="-120"/>
               </a:rPr>
               <a:t>18か月MMSE変化（有意差なし）</a:t>
             </a:r>
@@ -6178,9 +6332,9 @@
                 <a:solidFill>
                   <a:srgbClr val="333333"/>
                 </a:solidFill>
-                <a:latin typeface="Meiryo" pitchFamily="34" charset="0"/>
-                <a:ea typeface="Meiryo" pitchFamily="34" charset="-122"/>
-                <a:cs typeface="Meiryo" pitchFamily="34" charset="-120"/>
+                <a:latin typeface="Arial" pitchFamily="34" charset="0"/>
+                <a:ea typeface="ＭＳ Ｐゴシック" pitchFamily="34" charset="-122"/>
+                <a:cs typeface="Arial" pitchFamily="34" charset="-120"/>
               </a:rPr>
               <a:t>改善訴えあり +0.22点 / 記載なし −1.79点</a:t>
             </a:r>
@@ -6190,7 +6344,7 @@
       </p:sp>
       <p:graphicFrame>
         <p:nvGraphicFramePr>
-          <p:cNvPr id="6" name="Chart 0" descr=""/>
+          <p:cNvPr id="7" name="Chart 0" descr=""/>
           <p:cNvGraphicFramePr/>
           <p:nvPr/>
         </p:nvGraphicFramePr>
@@ -6206,7 +6360,7 @@
       </p:graphicFrame>
       <p:sp>
         <p:nvSpPr>
-          <p:cNvPr id="7" name="Text 4"/>
+          <p:cNvPr id="8" name="Text 5"/>
           <p:cNvSpPr/>
           <p:nvPr/>
         </p:nvSpPr>
@@ -6236,9 +6390,9 @@
                 <a:solidFill>
                   <a:srgbClr val="666666"/>
                 </a:solidFill>
-                <a:latin typeface="Meiryo" pitchFamily="34" charset="0"/>
-                <a:ea typeface="Meiryo" pitchFamily="34" charset="-122"/>
-                <a:cs typeface="Meiryo" pitchFamily="34" charset="-120"/>
+                <a:latin typeface="Arial" pitchFamily="34" charset="0"/>
+                <a:ea typeface="ＭＳ Ｐゴシック" pitchFamily="34" charset="-122"/>
+                <a:cs typeface="Arial" pitchFamily="34" charset="-120"/>
               </a:rPr>
               <a:t>※ 改善訴えは、診療録に記載された自覚的または家族からの改善の訴えを集計した探索的結果。統一した精神症状評価尺度による前後比較ではない。</a:t>
             </a:r>
@@ -6307,9 +6461,9 @@
                 <a:solidFill>
                   <a:srgbClr val="1A1A1A"/>
                 </a:solidFill>
-                <a:latin typeface="Meiryo" pitchFamily="34" charset="0"/>
-                <a:ea typeface="Meiryo" pitchFamily="34" charset="-122"/>
-                <a:cs typeface="Meiryo" pitchFamily="34" charset="-120"/>
+                <a:latin typeface="Arial" pitchFamily="34" charset="0"/>
+                <a:ea typeface="ＭＳ Ｐゴシック" pitchFamily="34" charset="-122"/>
+                <a:cs typeface="Arial" pitchFamily="34" charset="-120"/>
               </a:rPr>
               <a:t>症状改善の訴え有無によるMMSE変化の比較</a:t>
             </a:r>
@@ -6346,9 +6500,9 @@
                 <a:solidFill>
                   <a:srgbClr val="666666"/>
                 </a:solidFill>
-                <a:latin typeface="Meiryo" pitchFamily="34" charset="0"/>
-                <a:ea typeface="Meiryo" pitchFamily="34" charset="-122"/>
-                <a:cs typeface="Meiryo" pitchFamily="34" charset="-120"/>
+                <a:latin typeface="Arial" pitchFamily="34" charset="0"/>
+                <a:ea typeface="ＭＳ Ｐゴシック" pitchFamily="34" charset="-122"/>
+                <a:cs typeface="Arial" pitchFamily="34" charset="-120"/>
               </a:rPr>
               <a:t>対象：改善訴えあり9例／改善訴えなし（記載なしを含む）24例</a:t>
             </a:r>
@@ -6358,7 +6512,30 @@
       </p:sp>
       <p:sp>
         <p:nvSpPr>
-          <p:cNvPr id="4" name="Text 2"/>
+          <p:cNvPr id="4" name="Shape 2"/>
+          <p:cNvSpPr/>
+          <p:nvPr/>
+        </p:nvSpPr>
+        <p:spPr>
+          <a:xfrm>
+            <a:off x="457200" y="1207008"/>
+            <a:ext cx="11277295" cy="0"/>
+          </a:xfrm>
+          <a:prstGeom prst="line">
+            <a:avLst/>
+          </a:prstGeom>
+          <a:noFill/>
+          <a:ln w="22225">
+            <a:solidFill>
+              <a:srgbClr val="156082"/>
+            </a:solidFill>
+            <a:prstDash val="solid"/>
+          </a:ln>
+        </p:spPr>
+      </p:sp>
+      <p:sp>
+        <p:nvSpPr>
+          <p:cNvPr id="5" name="Text 3"/>
           <p:cNvSpPr/>
           <p:nvPr/>
         </p:nvSpPr>
@@ -6385,9 +6562,9 @@
                 <a:solidFill>
                   <a:srgbClr val="1A1A1A"/>
                 </a:solidFill>
-                <a:latin typeface="Meiryo" pitchFamily="34" charset="0"/>
-                <a:ea typeface="Meiryo" pitchFamily="34" charset="-122"/>
-                <a:cs typeface="Meiryo" pitchFamily="34" charset="-120"/>
+                <a:latin typeface="Arial" pitchFamily="34" charset="0"/>
+                <a:ea typeface="ＭＳ Ｐゴシック" pitchFamily="34" charset="-122"/>
+                <a:cs typeface="Arial" pitchFamily="34" charset="-120"/>
               </a:rPr>
               <a:t>A. 18か月時点の群間比較</a:t>
             </a:r>
@@ -6397,7 +6574,7 @@
       </p:sp>
       <p:sp>
         <p:nvSpPr>
-          <p:cNvPr id="5" name="Text 3"/>
+          <p:cNvPr id="6" name="Text 4"/>
           <p:cNvSpPr/>
           <p:nvPr/>
         </p:nvSpPr>
@@ -6424,9 +6601,9 @@
                 <a:solidFill>
                   <a:srgbClr val="1A1A1A"/>
                 </a:solidFill>
-                <a:latin typeface="Meiryo" pitchFamily="34" charset="0"/>
-                <a:ea typeface="Meiryo" pitchFamily="34" charset="-122"/>
-                <a:cs typeface="Meiryo" pitchFamily="34" charset="-120"/>
+                <a:latin typeface="Arial" pitchFamily="34" charset="0"/>
+                <a:ea typeface="ＭＳ Ｐゴシック" pitchFamily="34" charset="-122"/>
+                <a:cs typeface="Arial" pitchFamily="34" charset="-120"/>
               </a:rPr>
               <a:t>B. 経時的な平均変化量の推移</a:t>
             </a:r>
@@ -6436,7 +6613,7 @@
       </p:sp>
       <p:graphicFrame>
         <p:nvGraphicFramePr>
-          <p:cNvPr id="6" name="Chart 0" descr=""/>
+          <p:cNvPr id="7" name="Chart 0" descr=""/>
           <p:cNvGraphicFramePr/>
           <p:nvPr/>
         </p:nvGraphicFramePr>
@@ -6452,7 +6629,7 @@
       </p:graphicFrame>
       <p:graphicFrame>
         <p:nvGraphicFramePr>
-          <p:cNvPr id="7" name="Chart 1" descr=""/>
+          <p:cNvPr id="8" name="Chart 1" descr=""/>
           <p:cNvGraphicFramePr/>
           <p:nvPr/>
         </p:nvGraphicFramePr>
@@ -6468,7 +6645,7 @@
       </p:graphicFrame>
       <p:sp>
         <p:nvSpPr>
-          <p:cNvPr id="8" name="Text 4"/>
+          <p:cNvPr id="9" name="Text 5"/>
           <p:cNvSpPr/>
           <p:nvPr/>
         </p:nvSpPr>
@@ -6498,9 +6675,9 @@
                 <a:solidFill>
                   <a:srgbClr val="666666"/>
                 </a:solidFill>
-                <a:latin typeface="Meiryo" pitchFamily="34" charset="0"/>
-                <a:ea typeface="Meiryo" pitchFamily="34" charset="-122"/>
-                <a:cs typeface="Meiryo" pitchFamily="34" charset="-120"/>
+                <a:latin typeface="Arial" pitchFamily="34" charset="0"/>
+                <a:ea typeface="ＭＳ Ｐゴシック" pitchFamily="34" charset="-122"/>
+                <a:cs typeface="Arial" pitchFamily="34" charset="-120"/>
               </a:rPr>
               <a:t>統計：Welchのt検定 p=0.275、Mann-Whitney検定 p=0.100、ベースラインMMSE調整 p=0.600。数値上は改善訴えあり群で低下が少なかったが、いずれの解析でも統計学的有意差はなし。「改善訴えなし」には改善訴えの記載がない症例を含む。</a:t>
             </a:r>

</xml_diff>

<commit_message>
Update deck data after case exclusions from the source dataset
Cases were excluded from the underlying cohort, so several analyses'
denominators and results shifted. Updated affected slides only:
- Delayed-recall decline: n=33->29, McNemar p=0.031->0.063,
  normal->decline 6->5, and added the "低下=0-1点、正常=2-3点" definition
  line the physician wants shown; chart values recalculated accordingly
  (0か月 78.8/21.2->79.3/20.7, 18か月 97.0/3.0->96.6/3.4).
- Improvement-claim group MMSE change: n=24->20, -1.79->-0.75pt at 18mo,
  the full 6/12/18/24-month trend series, and all three p-values
  (Welch/Mann-Whitney/baseline-adjusted).
- Psychiatric-symptom slide's supplementary MMSE comparison box updated
  to match (n=20, -0.75pt).
MMSE-trend slide (unaffected subset) and Baseline table (unaffected
n=66 cohort) left unchanged, matching the newly supplied reference data.
</commit_message>
<xml_diff>
--- a/lecanemab-slides/lecanemab_analysis_slides.pptx
+++ b/lecanemab-slides/lecanemab_analysis_slides.pptx
@@ -163,7 +163,7 @@
                         <a:latin typeface="Arial"/>
                         <a:ea typeface="ＭＳ Ｐゴシック"/>
                       </a:rPr>
-                      <a:t>26/33</a:t>
+                      <a:t>23/29</a:t>
                     </a:r>
                   </a:p>
                   <a:p>
@@ -178,7 +178,7 @@
                         <a:latin typeface="Arial"/>
                         <a:ea typeface="ＭＳ Ｐゴシック"/>
                       </a:rPr>
-                      <a:t>(78.8%)</a:t>
+                      <a:t>(79.3%)</a:t>
                     </a:r>
                   </a:p>
                 </c:rich>
@@ -209,7 +209,7 @@
                         <a:latin typeface="Arial"/>
                         <a:ea typeface="ＭＳ Ｐゴシック"/>
                       </a:rPr>
-                      <a:t>32/33</a:t>
+                      <a:t>28/29</a:t>
                     </a:r>
                   </a:p>
                   <a:p>
@@ -224,7 +224,7 @@
                         <a:latin typeface="Arial"/>
                         <a:ea typeface="ＭＳ Ｐゴシック"/>
                       </a:rPr>
-                      <a:t>(97.0%)</a:t>
+                      <a:t>(96.6%)</a:t>
                     </a:r>
                   </a:p>
                 </c:rich>
@@ -283,10 +283,10 @@
                 <c:formatCode>General</c:formatCode>
                 <c:ptCount val="2"/>
                 <c:pt idx="0">
-                  <c:v>78.8</c:v>
+                  <c:v>79.3</c:v>
                 </c:pt>
                 <c:pt idx="1">
-                  <c:v>97</c:v>
+                  <c:v>96.6</c:v>
                 </c:pt>
               </c:numCache>
             </c:numRef>
@@ -332,7 +332,7 @@
                         <a:latin typeface="Arial"/>
                         <a:ea typeface="ＭＳ Ｐゴシック"/>
                       </a:rPr>
-                      <a:t>7/33</a:t>
+                      <a:t>6/29</a:t>
                     </a:r>
                   </a:p>
                   <a:p>
@@ -347,7 +347,7 @@
                         <a:latin typeface="Arial"/>
                         <a:ea typeface="ＭＳ Ｐゴシック"/>
                       </a:rPr>
-                      <a:t>(21.2%)</a:t>
+                      <a:t>(20.7%)</a:t>
                     </a:r>
                   </a:p>
                 </c:rich>
@@ -378,7 +378,7 @@
                         <a:latin typeface="Arial"/>
                         <a:ea typeface="ＭＳ Ｐゴシック"/>
                       </a:rPr>
-                      <a:t>1/33</a:t>
+                      <a:t>1/29</a:t>
                     </a:r>
                   </a:p>
                   <a:p>
@@ -393,7 +393,7 @@
                         <a:latin typeface="Arial"/>
                         <a:ea typeface="ＭＳ Ｐゴシック"/>
                       </a:rPr>
-                      <a:t>(3.0%)</a:t>
+                      <a:t>(3.4%)</a:t>
                     </a:r>
                   </a:p>
                 </c:rich>
@@ -452,10 +452,10 @@
                 <c:formatCode>General</c:formatCode>
                 <c:ptCount val="2"/>
                 <c:pt idx="0">
-                  <c:v>21.2</c:v>
+                  <c:v>20.7</c:v>
                 </c:pt>
                 <c:pt idx="1">
-                  <c:v>3</c:v>
+                  <c:v>3.4</c:v>
                 </c:pt>
               </c:numCache>
             </c:numRef>
@@ -1965,7 +1965,7 @@
                         <a:latin typeface="Arial"/>
                         <a:ea typeface="ＭＳ Ｐゴシック"/>
                       </a:rPr>
-                      <a:t>-1.79</a:t>
+                      <a:t>-0.75</a:t>
                     </a:r>
                   </a:p>
                 </c:rich>
@@ -2035,7 +2035,7 @@
                   </c:pt>
                   <c:pt idx="1">
                     <c:v>改善訴えなし
-(n=24)</c:v>
+(n=20)</c:v>
                   </c:pt>
                 </c:lvl>
               </c:multiLvlStrCache>
@@ -2051,7 +2051,7 @@
                   <c:v>0.22</c:v>
                 </c:pt>
                 <c:pt idx="1">
-                  <c:v>-1.79</c:v>
+                  <c:v>-0.75</c:v>
                 </c:pt>
               </c:numCache>
             </c:numRef>
@@ -2561,7 +2561,7 @@
                         <a:latin typeface="Arial"/>
                         <a:ea typeface="ＭＳ Ｐゴシック"/>
                       </a:rPr>
-                      <a:t>-0.49</a:t>
+                      <a:t>-0.53</a:t>
                     </a:r>
                   </a:p>
                   <a:p>
@@ -2576,7 +2576,7 @@
                         <a:latin typeface="Arial"/>
                         <a:ea typeface="ＭＳ Ｐゴシック"/>
                       </a:rPr>
-                      <a:t>(n=45)</a:t>
+                      <a:t>(n=43)</a:t>
                     </a:r>
                   </a:p>
                 </c:rich>
@@ -2591,6 +2591,98 @@
             </c:dLbl>
             <c:dLbl>
               <c:idx val="1"/>
+              <c:tx>
+                <c:rich>
+                  <a:bodyPr wrap="square" lIns="0" tIns="0" rIns="0" bIns="0" anchor="ctr"/>
+                  <a:lstStyle/>
+                  <a:p>
+                    <a:pPr algn="ctr">
+                      <a:defRPr sz="1000"/>
+                    </a:pPr>
+                    <a:r>
+                      <a:rPr lang="ja-JP" sz="1000" b="1">
+                        <a:solidFill>
+                          <a:srgbClr val="1A1A1A"/>
+                        </a:solidFill>
+                        <a:latin typeface="Arial"/>
+                        <a:ea typeface="ＭＳ Ｐゴシック"/>
+                      </a:rPr>
+                      <a:t>-0.50</a:t>
+                    </a:r>
+                  </a:p>
+                  <a:p>
+                    <a:pPr algn="ctr">
+                      <a:defRPr sz="900"/>
+                    </a:pPr>
+                    <a:r>
+                      <a:rPr lang="ja-JP" sz="900" b="0">
+                        <a:solidFill>
+                          <a:srgbClr val="1A1A1A"/>
+                        </a:solidFill>
+                        <a:latin typeface="Arial"/>
+                        <a:ea typeface="ＭＳ Ｐゴシック"/>
+                      </a:rPr>
+                      <a:t>(n=36)</a:t>
+                    </a:r>
+                  </a:p>
+                </c:rich>
+              </c:tx>
+              <c:dLblPos val="t"/>
+              <c:showLegendKey val="0"/>
+              <c:showVal val="0"/>
+              <c:showCatName val="0"/>
+              <c:showSerName val="0"/>
+              <c:showPercent val="0"/>
+              <c:showBubbleSize val="0"/>
+            </c:dLbl>
+            <c:dLbl>
+              <c:idx val="2"/>
+              <c:tx>
+                <c:rich>
+                  <a:bodyPr wrap="square" lIns="0" tIns="0" rIns="0" bIns="0" anchor="ctr"/>
+                  <a:lstStyle/>
+                  <a:p>
+                    <a:pPr algn="ctr">
+                      <a:defRPr sz="1000"/>
+                    </a:pPr>
+                    <a:r>
+                      <a:rPr lang="ja-JP" sz="1000" b="1">
+                        <a:solidFill>
+                          <a:srgbClr val="1A1A1A"/>
+                        </a:solidFill>
+                        <a:latin typeface="Arial"/>
+                        <a:ea typeface="ＭＳ Ｐゴシック"/>
+                      </a:rPr>
+                      <a:t>-0.75</a:t>
+                    </a:r>
+                  </a:p>
+                  <a:p>
+                    <a:pPr algn="ctr">
+                      <a:defRPr sz="900"/>
+                    </a:pPr>
+                    <a:r>
+                      <a:rPr lang="ja-JP" sz="900" b="0">
+                        <a:solidFill>
+                          <a:srgbClr val="1A1A1A"/>
+                        </a:solidFill>
+                        <a:latin typeface="Arial"/>
+                        <a:ea typeface="ＭＳ Ｐゴシック"/>
+                      </a:rPr>
+                      <a:t>(n=20)</a:t>
+                    </a:r>
+                  </a:p>
+                </c:rich>
+              </c:tx>
+              <c:dLblPos val="t"/>
+              <c:showLegendKey val="0"/>
+              <c:showVal val="0"/>
+              <c:showCatName val="0"/>
+              <c:showSerName val="0"/>
+              <c:showPercent val="0"/>
+              <c:showBubbleSize val="0"/>
+            </c:dLbl>
+            <c:dLbl>
+              <c:idx val="3"/>
               <c:tx>
                 <c:rich>
                   <a:bodyPr wrap="square" lIns="0" tIns="0" rIns="0" bIns="0" anchor="ctr"/>
@@ -2622,99 +2714,7 @@
                         <a:latin typeface="Arial"/>
                         <a:ea typeface="ＭＳ Ｐゴシック"/>
                       </a:rPr>
-                      <a:t>(n=37)</a:t>
-                    </a:r>
-                  </a:p>
-                </c:rich>
-              </c:tx>
-              <c:dLblPos val="t"/>
-              <c:showLegendKey val="0"/>
-              <c:showVal val="0"/>
-              <c:showCatName val="0"/>
-              <c:showSerName val="0"/>
-              <c:showPercent val="0"/>
-              <c:showBubbleSize val="0"/>
-            </c:dLbl>
-            <c:dLbl>
-              <c:idx val="2"/>
-              <c:tx>
-                <c:rich>
-                  <a:bodyPr wrap="square" lIns="0" tIns="0" rIns="0" bIns="0" anchor="ctr"/>
-                  <a:lstStyle/>
-                  <a:p>
-                    <a:pPr algn="ctr">
-                      <a:defRPr sz="1000"/>
-                    </a:pPr>
-                    <a:r>
-                      <a:rPr lang="ja-JP" sz="1000" b="1">
-                        <a:solidFill>
-                          <a:srgbClr val="1A1A1A"/>
-                        </a:solidFill>
-                        <a:latin typeface="Arial"/>
-                        <a:ea typeface="ＭＳ Ｐゴシック"/>
-                      </a:rPr>
-                      <a:t>-1.79</a:t>
-                    </a:r>
-                  </a:p>
-                  <a:p>
-                    <a:pPr algn="ctr">
-                      <a:defRPr sz="900"/>
-                    </a:pPr>
-                    <a:r>
-                      <a:rPr lang="ja-JP" sz="900" b="0">
-                        <a:solidFill>
-                          <a:srgbClr val="1A1A1A"/>
-                        </a:solidFill>
-                        <a:latin typeface="Arial"/>
-                        <a:ea typeface="ＭＳ Ｐゴシック"/>
-                      </a:rPr>
-                      <a:t>(n=24)</a:t>
-                    </a:r>
-                  </a:p>
-                </c:rich>
-              </c:tx>
-              <c:dLblPos val="t"/>
-              <c:showLegendKey val="0"/>
-              <c:showVal val="0"/>
-              <c:showCatName val="0"/>
-              <c:showSerName val="0"/>
-              <c:showPercent val="0"/>
-              <c:showBubbleSize val="0"/>
-            </c:dLbl>
-            <c:dLbl>
-              <c:idx val="3"/>
-              <c:tx>
-                <c:rich>
-                  <a:bodyPr wrap="square" lIns="0" tIns="0" rIns="0" bIns="0" anchor="ctr"/>
-                  <a:lstStyle/>
-                  <a:p>
-                    <a:pPr algn="ctr">
-                      <a:defRPr sz="1000"/>
-                    </a:pPr>
-                    <a:r>
-                      <a:rPr lang="ja-JP" sz="1000" b="1">
-                        <a:solidFill>
-                          <a:srgbClr val="1A1A1A"/>
-                        </a:solidFill>
-                        <a:latin typeface="Arial"/>
-                        <a:ea typeface="ＭＳ Ｐゴシック"/>
-                      </a:rPr>
-                      <a:t>-2.70</a:t>
-                    </a:r>
-                  </a:p>
-                  <a:p>
-                    <a:pPr algn="ctr">
-                      <a:defRPr sz="900"/>
-                    </a:pPr>
-                    <a:r>
-                      <a:rPr lang="ja-JP" sz="900" b="0">
-                        <a:solidFill>
-                          <a:srgbClr val="1A1A1A"/>
-                        </a:solidFill>
-                        <a:latin typeface="Arial"/>
-                        <a:ea typeface="ＭＳ Ｐゴシック"/>
-                      </a:rPr>
-                      <a:t>(n=10)</a:t>
+                      <a:t>(n=7)</a:t>
                     </a:r>
                   </a:p>
                 </c:rich>
@@ -2797,16 +2797,16 @@
                 <c:formatCode>General</c:formatCode>
                 <c:ptCount val="4"/>
                 <c:pt idx="0">
-                  <c:v>-0.49</c:v>
+                  <c:v>-0.53</c:v>
                 </c:pt>
                 <c:pt idx="1">
-                  <c:v>-0.57</c:v>
+                  <c:v>-0.5</c:v>
                 </c:pt>
                 <c:pt idx="2">
-                  <c:v>-1.79</c:v>
+                  <c:v>-0.75</c:v>
                 </c:pt>
                 <c:pt idx="3">
-                  <c:v>-2.7</c:v>
+                  <c:v>-0.57</c:v>
                 </c:pt>
               </c:numCache>
             </c:numRef>
@@ -4149,7 +4149,7 @@
         <p:spPr>
           <a:xfrm>
             <a:off x="457200" y="868680"/>
-            <a:ext cx="7315200" cy="320040"/>
+            <a:ext cx="7315200" cy="246888"/>
           </a:xfrm>
           <a:prstGeom prst="rect">
             <a:avLst/>
@@ -4173,7 +4173,7 @@
                 <a:ea typeface="ＭＳ Ｐゴシック" pitchFamily="34" charset="-122"/>
                 <a:cs typeface="Arial" pitchFamily="34" charset="-120"/>
               </a:rPr>
-              <a:t>対象：0か月・18か月の両時点で評価できた33例</a:t>
+              <a:t>定義：低下＝0-1点、正常＝2-3点</a:t>
             </a:r>
             <a:endParaRPr lang="en-US" sz="1300" dirty="0"/>
           </a:p>
@@ -4181,13 +4181,52 @@
       </p:sp>
       <p:sp>
         <p:nvSpPr>
-          <p:cNvPr id="4" name="Shape 2"/>
+          <p:cNvPr id="4" name="Text 2"/>
           <p:cNvSpPr/>
           <p:nvPr/>
         </p:nvSpPr>
         <p:spPr>
           <a:xfrm>
-            <a:off x="457200" y="1207008"/>
+            <a:off x="457200" y="1115568"/>
+            <a:ext cx="7315200" cy="246888"/>
+          </a:xfrm>
+          <a:prstGeom prst="rect">
+            <a:avLst/>
+          </a:prstGeom>
+          <a:noFill/>
+          <a:ln/>
+        </p:spPr>
+        <p:txBody>
+          <a:bodyPr wrap="square" lIns="0" tIns="0" rIns="0" bIns="0" rtlCol="0" anchor="t"/>
+          <a:lstStyle/>
+          <a:p>
+            <a:pPr algn="l" indent="0" marL="0">
+              <a:buNone/>
+            </a:pPr>
+            <a:r>
+              <a:rPr lang="en-US" sz="1300" dirty="0">
+                <a:solidFill>
+                  <a:srgbClr val="666666"/>
+                </a:solidFill>
+                <a:latin typeface="Arial" pitchFamily="34" charset="0"/>
+                <a:ea typeface="ＭＳ Ｐゴシック" pitchFamily="34" charset="-122"/>
+                <a:cs typeface="Arial" pitchFamily="34" charset="-120"/>
+              </a:rPr>
+              <a:t>対象：0か月・18か月の両時点で評価できた29例</a:t>
+            </a:r>
+            <a:endParaRPr lang="en-US" sz="1300" dirty="0"/>
+          </a:p>
+        </p:txBody>
+      </p:sp>
+      <p:sp>
+        <p:nvSpPr>
+          <p:cNvPr id="5" name="Shape 3"/>
+          <p:cNvSpPr/>
+          <p:nvPr/>
+        </p:nvSpPr>
+        <p:spPr>
+          <a:xfrm>
+            <a:off x="457200" y="1408176"/>
             <a:ext cx="11277295" cy="0"/>
           </a:xfrm>
           <a:prstGeom prst="line">
@@ -4204,7 +4243,7 @@
       </p:sp>
       <p:sp>
         <p:nvSpPr>
-          <p:cNvPr id="5" name="Shape 3"/>
+          <p:cNvPr id="6" name="Shape 4"/>
           <p:cNvSpPr/>
           <p:nvPr/>
         </p:nvSpPr>
@@ -4231,7 +4270,7 @@
       </p:sp>
       <p:sp>
         <p:nvSpPr>
-          <p:cNvPr id="6" name="Text 4"/>
+          <p:cNvPr id="7" name="Text 5"/>
           <p:cNvSpPr/>
           <p:nvPr/>
         </p:nvSpPr>
@@ -4265,7 +4304,7 @@
                 <a:ea typeface="ＭＳ Ｐゴシック" pitchFamily="34" charset="-122"/>
                 <a:cs typeface="Arial" pitchFamily="34" charset="-120"/>
               </a:rPr>
-              <a:t>McNemar正確検定 p = 0.031</a:t>
+              <a:t>McNemar正確検定 p = 0.063</a:t>
             </a:r>
             <a:endParaRPr lang="en-US" sz="1300" dirty="0"/>
           </a:p>
@@ -4285,7 +4324,7 @@
                 <a:ea typeface="ＭＳ Ｐゴシック" pitchFamily="34" charset="-122"/>
                 <a:cs typeface="Arial" pitchFamily="34" charset="-120"/>
               </a:rPr>
-              <a:t>正常→低下：6例、低下→正常：0例</a:t>
+              <a:t>正常→低下：5例、低下→正常：0例</a:t>
             </a:r>
             <a:endParaRPr lang="en-US" sz="1300" dirty="0"/>
           </a:p>
@@ -4293,13 +4332,13 @@
       </p:sp>
       <p:graphicFrame>
         <p:nvGraphicFramePr>
-          <p:cNvPr id="7" name="Chart 0" descr=""/>
+          <p:cNvPr id="8" name="Chart 0" descr=""/>
           <p:cNvGraphicFramePr/>
           <p:nvPr/>
         </p:nvGraphicFramePr>
         <p:xfrm>
-          <a:off x="822960" y="1536192"/>
-          <a:ext cx="10515600" cy="4572000"/>
+          <a:off x="822960" y="1755648"/>
+          <a:ext cx="10515600" cy="4434840"/>
         </p:xfrm>
         <a:graphic xmlns:a="http://schemas.openxmlformats.org/drawingml/2006/main">
           <a:graphicData uri="http://schemas.openxmlformats.org/drawingml/2006/chart">
@@ -5915,7 +5954,7 @@
         <p:spPr>
           <a:xfrm>
             <a:off x="457200" y="868680"/>
-            <a:ext cx="7315200" cy="320040"/>
+            <a:ext cx="7315200" cy="246888"/>
           </a:xfrm>
           <a:prstGeom prst="rect">
             <a:avLst/>
@@ -5953,7 +5992,7 @@
         </p:nvSpPr>
         <p:spPr>
           <a:xfrm>
-            <a:off x="457200" y="1207008"/>
+            <a:off x="457200" y="1161288"/>
             <a:ext cx="11277295" cy="0"/>
           </a:xfrm>
           <a:prstGeom prst="line">
@@ -6200,7 +6239,7 @@
         <p:spPr>
           <a:xfrm>
             <a:off x="457200" y="868680"/>
-            <a:ext cx="7223760" cy="320040"/>
+            <a:ext cx="7223760" cy="246888"/>
           </a:xfrm>
           <a:prstGeom prst="rect">
             <a:avLst/>
@@ -6238,7 +6277,7 @@
         </p:nvSpPr>
         <p:spPr>
           <a:xfrm>
-            <a:off x="457200" y="1207008"/>
+            <a:off x="457200" y="1161288"/>
             <a:ext cx="11277295" cy="0"/>
           </a:xfrm>
           <a:prstGeom prst="line">
@@ -6336,7 +6375,7 @@
                 <a:ea typeface="ＭＳ Ｐゴシック" pitchFamily="34" charset="-122"/>
                 <a:cs typeface="Arial" pitchFamily="34" charset="-120"/>
               </a:rPr>
-              <a:t>改善訴えあり +0.22点 / 記載なし −1.79点</a:t>
+              <a:t>改善訴えあり +0.22点 / 記載なし −0.75点</a:t>
             </a:r>
             <a:endParaRPr lang="en-US" sz="1250" dirty="0"/>
           </a:p>
@@ -6480,7 +6519,7 @@
         <p:spPr>
           <a:xfrm>
             <a:off x="457200" y="868680"/>
-            <a:ext cx="7315200" cy="320040"/>
+            <a:ext cx="7315200" cy="246888"/>
           </a:xfrm>
           <a:prstGeom prst="rect">
             <a:avLst/>
@@ -6504,7 +6543,7 @@
                 <a:ea typeface="ＭＳ Ｐゴシック" pitchFamily="34" charset="-122"/>
                 <a:cs typeface="Arial" pitchFamily="34" charset="-120"/>
               </a:rPr>
-              <a:t>対象：改善訴えあり9例／改善訴えなし（記載なしを含む）24例</a:t>
+              <a:t>対象：改善訴えあり9例／改善訴えなし（記載なしを含む）20例</a:t>
             </a:r>
             <a:endParaRPr lang="en-US" sz="1300" dirty="0"/>
           </a:p>
@@ -6518,7 +6557,7 @@
         </p:nvSpPr>
         <p:spPr>
           <a:xfrm>
-            <a:off x="457200" y="1207008"/>
+            <a:off x="457200" y="1161288"/>
             <a:ext cx="11277295" cy="0"/>
           </a:xfrm>
           <a:prstGeom prst="line">
@@ -6679,7 +6718,7 @@
                 <a:ea typeface="ＭＳ Ｐゴシック" pitchFamily="34" charset="-122"/>
                 <a:cs typeface="Arial" pitchFamily="34" charset="-120"/>
               </a:rPr>
-              <a:t>統計：Welchのt検定 p=0.275、Mann-Whitney検定 p=0.100、ベースラインMMSE調整 p=0.600。数値上は改善訴えあり群で低下が少なかったが、いずれの解析でも統計学的有意差はなし。「改善訴えなし」には改善訴えの記載がない症例を含む。</a:t>
+              <a:t>統計：Welchのt検定 p=0.581、Mann-Whitney検定 p=0.200、ベースラインMMSE調整 p=0.879。数値上は改善訴えあり群で低下が少なかったが、いずれの解析でも統計学的有意差はなし。「改善訴えなし」には改善訴えの記載がない症例を含む。</a:t>
             </a:r>
             <a:endParaRPr lang="en-US" sz="1050" dirty="0"/>
           </a:p>

</xml_diff>

<commit_message>
Update MMSE-trend slide with the previously missing case-exclusion data
The MMSE-trend slide was left unchanged in the last update because no
revised reference was supplied for it; it's now in. n at each timepoint
drops (66/59/48/29/13 vs 66/61/49/33/16), so both panels and the
footnote's paired analysis (-0.45pt, 0か月23.83->18か月23.38,
p=0.494/0.786) change accordingly. Panel B's headline emphasis moves
from 低下 to 改善, since 改善 is now the largest single category
(44.8% vs 41.4%).
</commit_message>
<xml_diff>
--- a/lecanemab-slides/lecanemab_analysis_slides.pptx
+++ b/lecanemab-slides/lecanemab_analysis_slides.pptx
@@ -727,7 +727,7 @@
                         <a:latin typeface="Arial"/>
                         <a:ea typeface="ＭＳ Ｐゴシック"/>
                       </a:rPr>
-                      <a:t>0.00</a:t>
+                      <a:t>-0.02</a:t>
                     </a:r>
                   </a:p>
                   <a:p>
@@ -742,7 +742,7 @@
                         <a:latin typeface="Arial"/>
                         <a:ea typeface="ＭＳ Ｐゴシック"/>
                       </a:rPr>
-                      <a:t>(n=61)</a:t>
+                      <a:t>(n=59)</a:t>
                     </a:r>
                   </a:p>
                 </c:rich>
@@ -773,7 +773,7 @@
                         <a:latin typeface="Arial"/>
                         <a:ea typeface="ＭＳ Ｐゴシック"/>
                       </a:rPr>
-                      <a:t>-0.35</a:t>
+                      <a:t>-0.29</a:t>
                     </a:r>
                   </a:p>
                   <a:p>
@@ -788,7 +788,7 @@
                         <a:latin typeface="Arial"/>
                         <a:ea typeface="ＭＳ Ｐゴシック"/>
                       </a:rPr>
-                      <a:t>(n=49)</a:t>
+                      <a:t>(n=48)</a:t>
                     </a:r>
                   </a:p>
                 </c:rich>
@@ -819,7 +819,7 @@
                         <a:latin typeface="Arial"/>
                         <a:ea typeface="ＭＳ Ｐゴシック"/>
                       </a:rPr>
-                      <a:t>-1.24</a:t>
+                      <a:t>-0.45</a:t>
                     </a:r>
                   </a:p>
                   <a:p>
@@ -834,7 +834,7 @@
                         <a:latin typeface="Arial"/>
                         <a:ea typeface="ＭＳ Ｐゴシック"/>
                       </a:rPr>
-                      <a:t>(n=33)</a:t>
+                      <a:t>(n=29)</a:t>
                     </a:r>
                   </a:p>
                 </c:rich>
@@ -865,7 +865,7 @@
                         <a:latin typeface="Arial"/>
                         <a:ea typeface="ＭＳ Ｐゴシック"/>
                       </a:rPr>
-                      <a:t>-1.75</a:t>
+                      <a:t>-0.38</a:t>
                     </a:r>
                   </a:p>
                   <a:p>
@@ -880,7 +880,7 @@
                         <a:latin typeface="Arial"/>
                         <a:ea typeface="ＭＳ Ｐゴシック"/>
                       </a:rPr>
-                      <a:t>(n=16)</a:t>
+                      <a:t>(n=13)</a:t>
                     </a:r>
                   </a:p>
                 </c:rich>
@@ -951,16 +951,16 @@
                   <c:v>0</c:v>
                 </c:pt>
                 <c:pt idx="1">
-                  <c:v>0</c:v>
+                  <c:v>-0.02</c:v>
                 </c:pt>
                 <c:pt idx="2">
-                  <c:v>-0.35</c:v>
+                  <c:v>-0.29</c:v>
                 </c:pt>
                 <c:pt idx="3">
-                  <c:v>-1.24</c:v>
+                  <c:v>-0.45</c:v>
                 </c:pt>
                 <c:pt idx="4">
-                  <c:v>-1.75</c:v>
+                  <c:v>-0.38</c:v>
                 </c:pt>
               </c:numCache>
             </c:numRef>
@@ -1161,7 +1161,7 @@
                     <a:r>
                       <a:rPr lang="ja-JP" sz="1200" b="1">
                         <a:solidFill>
-                          <a:srgbClr val="1A1A1A"/>
+                          <a:srgbClr val="FF0000"/>
                         </a:solidFill>
                         <a:latin typeface="Arial"/>
                         <a:ea typeface="ＭＳ Ｐゴシック"/>
@@ -1176,12 +1176,12 @@
                     <a:r>
                       <a:rPr lang="ja-JP" sz="1100" b="0">
                         <a:solidFill>
-                          <a:srgbClr val="1A1A1A"/>
+                          <a:srgbClr val="FF0000"/>
                         </a:solidFill>
                         <a:latin typeface="Arial"/>
                         <a:ea typeface="ＭＳ Ｐゴシック"/>
                       </a:rPr>
-                      <a:t>(39.4%)</a:t>
+                      <a:t>(44.8%)</a:t>
                     </a:r>
                   </a:p>
                 </c:rich>
@@ -1227,7 +1227,7 @@
                         <a:latin typeface="Arial"/>
                         <a:ea typeface="ＭＳ Ｐゴシック"/>
                       </a:rPr>
-                      <a:t>(12.1%)</a:t>
+                      <a:t>(13.8%)</a:t>
                     </a:r>
                   </a:p>
                 </c:rich>
@@ -1253,12 +1253,12 @@
                     <a:r>
                       <a:rPr lang="ja-JP" sz="1200" b="1">
                         <a:solidFill>
-                          <a:srgbClr val="FF0000"/>
+                          <a:srgbClr val="1A1A1A"/>
                         </a:solidFill>
                         <a:latin typeface="Arial"/>
                         <a:ea typeface="ＭＳ Ｐゴシック"/>
                       </a:rPr>
-                      <a:t>16例</a:t>
+                      <a:t>12例</a:t>
                     </a:r>
                   </a:p>
                   <a:p>
@@ -1268,12 +1268,12 @@
                     <a:r>
                       <a:rPr lang="ja-JP" sz="1100" b="0">
                         <a:solidFill>
-                          <a:srgbClr val="FF0000"/>
+                          <a:srgbClr val="1A1A1A"/>
                         </a:solidFill>
                         <a:latin typeface="Arial"/>
                         <a:ea typeface="ＭＳ Ｐゴシック"/>
                       </a:rPr>
-                      <a:t>(48.5%)</a:t>
+                      <a:t>(41.4%)</a:t>
                     </a:r>
                   </a:p>
                 </c:rich>
@@ -1371,13 +1371,13 @@
                 <c:formatCode>General</c:formatCode>
                 <c:ptCount val="3"/>
                 <c:pt idx="0">
-                  <c:v>39.4</c:v>
+                  <c:v>44.8</c:v>
                 </c:pt>
                 <c:pt idx="1">
-                  <c:v>12.1</c:v>
+                  <c:v>13.8</c:v>
                 </c:pt>
                 <c:pt idx="2">
-                  <c:v>48.5</c:v>
+                  <c:v>41.4</c:v>
                 </c:pt>
               </c:numCache>
             </c:numRef>
@@ -6079,7 +6079,7 @@
                 <a:ea typeface="ＭＳ Ｐゴシック" pitchFamily="34" charset="-122"/>
                 <a:cs typeface="Arial" pitchFamily="34" charset="-120"/>
               </a:rPr>
-              <a:t>B. 18か月時点の変化分類（n=33）</a:t>
+              <a:t>B. 18か月時点の変化分類（n=29）</a:t>
             </a:r>
             <a:endParaRPr lang="en-US" sz="1400" dirty="0"/>
           </a:p>
@@ -6153,7 +6153,7 @@
                 <a:ea typeface="ＭＳ Ｐゴシック" pitchFamily="34" charset="-122"/>
                 <a:cs typeface="Arial" pitchFamily="34" charset="-120"/>
               </a:rPr>
-              <a:t>18か月対応解析：平均変化 −1.24点（0か月23.91点→18か月22.67点）。対応のあるt検定 p=0.087、Wilcoxon符号付順位検定 p=0.188。※24か月は補助データ（n=16）。図中nは各時点での対応症例数。</a:t>
+              <a:t>18か月対応解析：平均変化 −0.45点（0か月23.83点→18か月23.38点）。対応のあるt検定 p=0.494、Wilcoxon符号付順位検定 p=0.786。※24か月は補助データ（n=13）。図中nは各時点での対応症例数。</a:t>
             </a:r>
             <a:endParaRPr lang="en-US" sz="1050" dirty="0"/>
           </a:p>

</xml_diff>